<commit_message>
update presentation_ru.pptx and tests
</commit_message>
<xml_diff>
--- a/doc/presentation_ru.pptx
+++ b/doc/presentation_ru.pptx
@@ -18,6 +18,7 @@
     <p:sldId id="268" r:id="rId12"/>
     <p:sldId id="269" r:id="rId13"/>
     <p:sldId id="270" r:id="rId14"/>
+    <p:sldId id="272" r:id="rId15"/>
   </p:sldIdLst>
   <p:sldSz cx="12192000" cy="6858000"/>
   <p:notesSz cx="6858000" cy="9144000"/>
@@ -271,7 +272,7 @@
           <a:p>
             <a:fld id="{55B4ADA0-5919-4E9A-86CC-FDD0BCB70E6E}" type="datetimeFigureOut">
               <a:rPr lang="ru-RU" smtClean="0"/>
-              <a:t>27.04.2026</a:t>
+              <a:t>07.05.2026</a:t>
             </a:fld>
             <a:endParaRPr lang="ru-RU"/>
           </a:p>
@@ -469,7 +470,7 @@
           <a:p>
             <a:fld id="{55B4ADA0-5919-4E9A-86CC-FDD0BCB70E6E}" type="datetimeFigureOut">
               <a:rPr lang="ru-RU" smtClean="0"/>
-              <a:t>27.04.2026</a:t>
+              <a:t>07.05.2026</a:t>
             </a:fld>
             <a:endParaRPr lang="ru-RU"/>
           </a:p>
@@ -677,7 +678,7 @@
           <a:p>
             <a:fld id="{55B4ADA0-5919-4E9A-86CC-FDD0BCB70E6E}" type="datetimeFigureOut">
               <a:rPr lang="ru-RU" smtClean="0"/>
-              <a:t>27.04.2026</a:t>
+              <a:t>07.05.2026</a:t>
             </a:fld>
             <a:endParaRPr lang="ru-RU"/>
           </a:p>
@@ -875,7 +876,7 @@
           <a:p>
             <a:fld id="{55B4ADA0-5919-4E9A-86CC-FDD0BCB70E6E}" type="datetimeFigureOut">
               <a:rPr lang="ru-RU" smtClean="0"/>
-              <a:t>27.04.2026</a:t>
+              <a:t>07.05.2026</a:t>
             </a:fld>
             <a:endParaRPr lang="ru-RU"/>
           </a:p>
@@ -1150,7 +1151,7 @@
           <a:p>
             <a:fld id="{55B4ADA0-5919-4E9A-86CC-FDD0BCB70E6E}" type="datetimeFigureOut">
               <a:rPr lang="ru-RU" smtClean="0"/>
-              <a:t>27.04.2026</a:t>
+              <a:t>07.05.2026</a:t>
             </a:fld>
             <a:endParaRPr lang="ru-RU"/>
           </a:p>
@@ -1415,7 +1416,7 @@
           <a:p>
             <a:fld id="{55B4ADA0-5919-4E9A-86CC-FDD0BCB70E6E}" type="datetimeFigureOut">
               <a:rPr lang="ru-RU" smtClean="0"/>
-              <a:t>27.04.2026</a:t>
+              <a:t>07.05.2026</a:t>
             </a:fld>
             <a:endParaRPr lang="ru-RU"/>
           </a:p>
@@ -1827,7 +1828,7 @@
           <a:p>
             <a:fld id="{55B4ADA0-5919-4E9A-86CC-FDD0BCB70E6E}" type="datetimeFigureOut">
               <a:rPr lang="ru-RU" smtClean="0"/>
-              <a:t>27.04.2026</a:t>
+              <a:t>07.05.2026</a:t>
             </a:fld>
             <a:endParaRPr lang="ru-RU"/>
           </a:p>
@@ -1968,7 +1969,7 @@
           <a:p>
             <a:fld id="{55B4ADA0-5919-4E9A-86CC-FDD0BCB70E6E}" type="datetimeFigureOut">
               <a:rPr lang="ru-RU" smtClean="0"/>
-              <a:t>27.04.2026</a:t>
+              <a:t>07.05.2026</a:t>
             </a:fld>
             <a:endParaRPr lang="ru-RU"/>
           </a:p>
@@ -2081,7 +2082,7 @@
           <a:p>
             <a:fld id="{55B4ADA0-5919-4E9A-86CC-FDD0BCB70E6E}" type="datetimeFigureOut">
               <a:rPr lang="ru-RU" smtClean="0"/>
-              <a:t>27.04.2026</a:t>
+              <a:t>07.05.2026</a:t>
             </a:fld>
             <a:endParaRPr lang="ru-RU"/>
           </a:p>
@@ -2392,7 +2393,7 @@
           <a:p>
             <a:fld id="{55B4ADA0-5919-4E9A-86CC-FDD0BCB70E6E}" type="datetimeFigureOut">
               <a:rPr lang="ru-RU" smtClean="0"/>
-              <a:t>27.04.2026</a:t>
+              <a:t>07.05.2026</a:t>
             </a:fld>
             <a:endParaRPr lang="ru-RU"/>
           </a:p>
@@ -2680,7 +2681,7 @@
           <a:p>
             <a:fld id="{55B4ADA0-5919-4E9A-86CC-FDD0BCB70E6E}" type="datetimeFigureOut">
               <a:rPr lang="ru-RU" smtClean="0"/>
-              <a:t>27.04.2026</a:t>
+              <a:t>07.05.2026</a:t>
             </a:fld>
             <a:endParaRPr lang="ru-RU"/>
           </a:p>
@@ -2921,7 +2922,7 @@
           <a:p>
             <a:fld id="{55B4ADA0-5919-4E9A-86CC-FDD0BCB70E6E}" type="datetimeFigureOut">
               <a:rPr lang="ru-RU" smtClean="0"/>
-              <a:t>27.04.2026</a:t>
+              <a:t>07.05.2026</a:t>
             </a:fld>
             <a:endParaRPr lang="ru-RU"/>
           </a:p>
@@ -4004,8 +4005,8 @@
         </p:nvSpPr>
         <p:spPr>
           <a:xfrm>
-            <a:off x="900187" y="1743519"/>
-            <a:ext cx="3794996" cy="3416320"/>
+            <a:off x="900186" y="1743519"/>
+            <a:ext cx="5614322" cy="4801314"/>
           </a:xfrm>
           <a:prstGeom prst="rect">
             <a:avLst/>
@@ -4030,25 +4031,43 @@
             </a:br>
             <a:r>
               <a:rPr lang="ru-RU" dirty="0"/>
-              <a:t>Систематическая ошибка может быть связана с точечным определением аналитической скорости. В отличии от </a:t>
-            </a:r>
-            <a:r>
-              <a:rPr lang="en-US" dirty="0"/>
-              <a:t>PIV</a:t>
-            </a:r>
+              <a:t>Наличие оптимального значения следует из двух наблюдений: </a:t>
+            </a:r>
+          </a:p>
+          <a:p>
+            <a:pPr marL="342900" indent="-342900">
+              <a:buAutoNum type="arabicParenR"/>
+            </a:pPr>
             <a:r>
               <a:rPr lang="ru-RU" dirty="0"/>
-              <a:t>, который выдает некоторое усредненное значение в окне заданного размера</a:t>
+              <a:t>При слишком маленьком количестве частиц (вырожденный случай одна) недостаточно информации, чтобы правильно восстановить поле</a:t>
+            </a:r>
+          </a:p>
+          <a:p>
+            <a:pPr marL="342900" indent="-342900">
+              <a:buAutoNum type="arabicParenR"/>
+            </a:pPr>
+            <a:r>
+              <a:rPr lang="ru-RU" dirty="0"/>
+              <a:t>При увеличении количества частиц в какой-то момент можно заменить пробелы между частицами на эффективные частицы (дырки) и интерпретировать восстановление течения по движению дырок, тогда возникает такая же проблема 1) при уменьшении количества дырок (вырожденный случай, когда весь экран в </a:t>
+            </a:r>
+            <a:r>
+              <a:rPr lang="ru-RU" dirty="0" err="1"/>
+              <a:t>частицых</a:t>
+            </a:r>
+            <a:r>
+              <a:rPr lang="ru-RU" dirty="0"/>
+              <a:t> без пробелов)</a:t>
             </a:r>
           </a:p>
         </p:txBody>
       </p:sp>
       <p:pic>
         <p:nvPicPr>
-          <p:cNvPr id="8" name="Рисунок 7">
-            <a:extLst>
-              <a:ext uri="{FF2B5EF4-FFF2-40B4-BE49-F238E27FC236}">
-                <a16:creationId xmlns:a16="http://schemas.microsoft.com/office/drawing/2014/main" id="{696CAAC1-9A72-43AC-82A9-E8DBC39FD859}"/>
+          <p:cNvPr id="4" name="Рисунок 3">
+            <a:extLst>
+              <a:ext uri="{FF2B5EF4-FFF2-40B4-BE49-F238E27FC236}">
+                <a16:creationId xmlns:a16="http://schemas.microsoft.com/office/drawing/2014/main" id="{BAB25C67-1182-4A04-83F7-F7865CE039ED}"/>
               </a:ext>
             </a:extLst>
           </p:cNvPr>
@@ -4065,8 +4084,8 @@
         </p:blipFill>
         <p:spPr>
           <a:xfrm>
-            <a:off x="6025157" y="1397658"/>
-            <a:ext cx="5897148" cy="4593793"/>
+            <a:off x="6348684" y="1560069"/>
+            <a:ext cx="5290274" cy="3919223"/>
           </a:xfrm>
           <a:prstGeom prst="rect">
             <a:avLst/>
@@ -4077,6 +4096,772 @@
     <p:extLst>
       <p:ext uri="{BB962C8B-B14F-4D97-AF65-F5344CB8AC3E}">
         <p14:creationId xmlns:p14="http://schemas.microsoft.com/office/powerpoint/2010/main" val="1409460611"/>
+      </p:ext>
+    </p:extLst>
+  </p:cSld>
+  <p:clrMapOvr>
+    <a:masterClrMapping/>
+  </p:clrMapOvr>
+</p:sld>
+</file>
+
+<file path=ppt/slides/slide14.xml><?xml version="1.0" encoding="utf-8"?>
+<p:sld xmlns:a="http://schemas.openxmlformats.org/drawingml/2006/main" xmlns:r="http://schemas.openxmlformats.org/officeDocument/2006/relationships" xmlns:p="http://schemas.openxmlformats.org/presentationml/2006/main">
+  <p:cSld>
+    <p:spTree>
+      <p:nvGrpSpPr>
+        <p:cNvPr id="1" name=""/>
+        <p:cNvGrpSpPr/>
+        <p:nvPr/>
+      </p:nvGrpSpPr>
+      <p:grpSpPr>
+        <a:xfrm>
+          <a:off x="0" y="0"/>
+          <a:ext cx="0" cy="0"/>
+          <a:chOff x="0" y="0"/>
+          <a:chExt cx="0" cy="0"/>
+        </a:xfrm>
+      </p:grpSpPr>
+      <p:sp>
+        <p:nvSpPr>
+          <p:cNvPr id="2" name="Заголовок 1">
+            <a:extLst>
+              <a:ext uri="{FF2B5EF4-FFF2-40B4-BE49-F238E27FC236}">
+                <a16:creationId xmlns:a16="http://schemas.microsoft.com/office/drawing/2014/main" id="{52601A20-83A2-4556-9F66-0D39C0D3C95C}"/>
+              </a:ext>
+            </a:extLst>
+          </p:cNvPr>
+          <p:cNvSpPr>
+            <a:spLocks noGrp="1"/>
+          </p:cNvSpPr>
+          <p:nvPr>
+            <p:ph type="title"/>
+          </p:nvPr>
+        </p:nvSpPr>
+        <p:spPr/>
+        <p:txBody>
+          <a:bodyPr/>
+          <a:lstStyle/>
+          <a:p>
+            <a:r>
+              <a:rPr lang="ru-RU" dirty="0">
+                <a:latin typeface="Bahnschrift SemiBold Condensed" panose="020B0502040204020203" pitchFamily="34" charset="0"/>
+              </a:rPr>
+              <a:t>Корректировка</a:t>
+            </a:r>
+            <a:endParaRPr lang="ru-RU" dirty="0"/>
+          </a:p>
+        </p:txBody>
+      </p:sp>
+      <mc:AlternateContent xmlns:mc="http://schemas.openxmlformats.org/markup-compatibility/2006">
+        <mc:Choice xmlns:a14="http://schemas.microsoft.com/office/drawing/2010/main" Requires="a14">
+          <p:sp>
+            <p:nvSpPr>
+              <p:cNvPr id="6" name="TextBox 5">
+                <a:extLst>
+                  <a:ext uri="{FF2B5EF4-FFF2-40B4-BE49-F238E27FC236}">
+                    <a16:creationId xmlns:a16="http://schemas.microsoft.com/office/drawing/2014/main" id="{37A5E661-2DD6-489C-81CA-B9C5D0158264}"/>
+                  </a:ext>
+                </a:extLst>
+              </p:cNvPr>
+              <p:cNvSpPr txBox="1"/>
+              <p:nvPr/>
+            </p:nvSpPr>
+            <p:spPr>
+              <a:xfrm>
+                <a:off x="904924" y="1743519"/>
+                <a:ext cx="5614322" cy="4118692"/>
+              </a:xfrm>
+              <a:prstGeom prst="rect">
+                <a:avLst/>
+              </a:prstGeom>
+              <a:noFill/>
+            </p:spPr>
+            <p:txBody>
+              <a:bodyPr wrap="square" rtlCol="0">
+                <a:spAutoFit/>
+              </a:bodyPr>
+              <a:lstStyle/>
+              <a:p>
+                <a:r>
+                  <a:rPr lang="ru-RU" dirty="0"/>
+                  <a:t>Так как течение предполагается несжимаемым это накладывает ограничения на скорости потока по уравнению неразрывности:</a:t>
+                </a:r>
+              </a:p>
+              <a:p>
+                <a14:m>
+                  <m:oMathPara xmlns:m="http://schemas.openxmlformats.org/officeDocument/2006/math">
+                    <m:oMathParaPr>
+                      <m:jc m:val="centerGroup"/>
+                    </m:oMathParaPr>
+                    <m:oMath xmlns:m="http://schemas.openxmlformats.org/officeDocument/2006/math">
+                      <m:sSub>
+                        <m:sSubPr>
+                          <m:ctrlPr>
+                            <a:rPr lang="en-US" b="0" i="1" smtClean="0">
+                              <a:latin typeface="Cambria Math" panose="02040503050406030204" pitchFamily="18" charset="0"/>
+                            </a:rPr>
+                          </m:ctrlPr>
+                        </m:sSubPr>
+                        <m:e>
+                          <m:r>
+                            <a:rPr lang="en-US" b="0" i="1" smtClean="0">
+                              <a:latin typeface="Cambria Math" panose="02040503050406030204" pitchFamily="18" charset="0"/>
+                            </a:rPr>
+                            <m:t>𝜕</m:t>
+                          </m:r>
+                        </m:e>
+                        <m:sub>
+                          <m:r>
+                            <a:rPr lang="en-US" b="0" i="1" smtClean="0">
+                              <a:latin typeface="Cambria Math" panose="02040503050406030204" pitchFamily="18" charset="0"/>
+                            </a:rPr>
+                            <m:t>𝑥</m:t>
+                          </m:r>
+                        </m:sub>
+                      </m:sSub>
+                      <m:r>
+                        <a:rPr lang="en-US" b="0" i="1" smtClean="0">
+                          <a:latin typeface="Cambria Math" panose="02040503050406030204" pitchFamily="18" charset="0"/>
+                        </a:rPr>
+                        <m:t>𝑢</m:t>
+                      </m:r>
+                      <m:r>
+                        <a:rPr lang="en-US" b="0" i="1" smtClean="0">
+                          <a:latin typeface="Cambria Math" panose="02040503050406030204" pitchFamily="18" charset="0"/>
+                        </a:rPr>
+                        <m:t>+</m:t>
+                      </m:r>
+                      <m:sSub>
+                        <m:sSubPr>
+                          <m:ctrlPr>
+                            <a:rPr lang="en-US" b="0" i="1" smtClean="0">
+                              <a:latin typeface="Cambria Math" panose="02040503050406030204" pitchFamily="18" charset="0"/>
+                            </a:rPr>
+                          </m:ctrlPr>
+                        </m:sSubPr>
+                        <m:e>
+                          <m:r>
+                            <a:rPr lang="en-US" b="0" i="1" smtClean="0">
+                              <a:latin typeface="Cambria Math" panose="02040503050406030204" pitchFamily="18" charset="0"/>
+                            </a:rPr>
+                            <m:t>𝜕</m:t>
+                          </m:r>
+                        </m:e>
+                        <m:sub>
+                          <m:r>
+                            <a:rPr lang="en-US" b="0" i="1" smtClean="0">
+                              <a:latin typeface="Cambria Math" panose="02040503050406030204" pitchFamily="18" charset="0"/>
+                            </a:rPr>
+                            <m:t>𝑦</m:t>
+                          </m:r>
+                        </m:sub>
+                      </m:sSub>
+                      <m:r>
+                        <a:rPr lang="en-US" b="0" i="1" smtClean="0">
+                          <a:latin typeface="Cambria Math" panose="02040503050406030204" pitchFamily="18" charset="0"/>
+                        </a:rPr>
+                        <m:t>𝑣</m:t>
+                      </m:r>
+                      <m:r>
+                        <a:rPr lang="en-US" b="0" i="1" smtClean="0">
+                          <a:latin typeface="Cambria Math" panose="02040503050406030204" pitchFamily="18" charset="0"/>
+                        </a:rPr>
+                        <m:t>=0</m:t>
+                      </m:r>
+                    </m:oMath>
+                  </m:oMathPara>
+                </a14:m>
+                <a:endParaRPr lang="en-US" dirty="0"/>
+              </a:p>
+              <a:p>
+                <a:r>
+                  <a:rPr lang="ru-RU" dirty="0"/>
+                  <a:t>В численном виде это можно свести к системе линейных уравнений, но размер системы будет </a:t>
+                </a:r>
+                <a14:m>
+                  <m:oMath xmlns:m="http://schemas.openxmlformats.org/officeDocument/2006/math">
+                    <m:r>
+                      <a:rPr lang="en-US" b="0" i="1" smtClean="0">
+                        <a:latin typeface="Cambria Math" panose="02040503050406030204" pitchFamily="18" charset="0"/>
+                      </a:rPr>
+                      <m:t>𝑛</m:t>
+                    </m:r>
+                  </m:oMath>
+                </a14:m>
+                <a:r>
+                  <a:rPr lang="en-US" dirty="0"/>
+                  <a:t> </a:t>
+                </a:r>
+                <a:r>
+                  <a:rPr lang="ru-RU" dirty="0"/>
+                  <a:t>при том, что количество неизвестных </a:t>
+                </a:r>
+                <a14:m>
+                  <m:oMath xmlns:m="http://schemas.openxmlformats.org/officeDocument/2006/math">
+                    <m:r>
+                      <a:rPr lang="en-US" b="0" i="1" smtClean="0">
+                        <a:latin typeface="Cambria Math" panose="02040503050406030204" pitchFamily="18" charset="0"/>
+                      </a:rPr>
+                      <m:t>2</m:t>
+                    </m:r>
+                    <m:r>
+                      <a:rPr lang="en-US" b="0" i="1" smtClean="0">
+                        <a:latin typeface="Cambria Math" panose="02040503050406030204" pitchFamily="18" charset="0"/>
+                      </a:rPr>
+                      <m:t>𝑛</m:t>
+                    </m:r>
+                  </m:oMath>
+                </a14:m>
+                <a:r>
+                  <a:rPr lang="en-US" dirty="0"/>
+                  <a:t> . </a:t>
+                </a:r>
+                <a:r>
+                  <a:rPr lang="ru-RU" dirty="0"/>
+                  <a:t>Система, как и должно быть, не доопределена. После работы алгоритма </a:t>
+                </a:r>
+                <a:r>
+                  <a:rPr lang="en-US" dirty="0"/>
+                  <a:t>PIV </a:t>
+                </a:r>
+                <a:r>
+                  <a:rPr lang="ru-RU" dirty="0"/>
+                  <a:t>имеется приближение решения </a:t>
+                </a:r>
+                <a14:m>
+                  <m:oMath xmlns:m="http://schemas.openxmlformats.org/officeDocument/2006/math">
+                    <m:d>
+                      <m:dPr>
+                        <m:ctrlPr>
+                          <a:rPr lang="en-US" b="0" i="1" smtClean="0">
+                            <a:latin typeface="Cambria Math" panose="02040503050406030204" pitchFamily="18" charset="0"/>
+                          </a:rPr>
+                        </m:ctrlPr>
+                      </m:dPr>
+                      <m:e>
+                        <m:sSup>
+                          <m:sSupPr>
+                            <m:ctrlPr>
+                              <a:rPr lang="en-US" b="0" i="1" smtClean="0">
+                                <a:latin typeface="Cambria Math" panose="02040503050406030204" pitchFamily="18" charset="0"/>
+                              </a:rPr>
+                            </m:ctrlPr>
+                          </m:sSupPr>
+                          <m:e>
+                            <m:r>
+                              <a:rPr lang="en-US" b="0" i="1" smtClean="0">
+                                <a:latin typeface="Cambria Math" panose="02040503050406030204" pitchFamily="18" charset="0"/>
+                              </a:rPr>
+                              <m:t>𝑢</m:t>
+                            </m:r>
+                          </m:e>
+                          <m:sup>
+                            <m:r>
+                              <a:rPr lang="en-US" b="0" i="1" smtClean="0">
+                                <a:latin typeface="Cambria Math" panose="02040503050406030204" pitchFamily="18" charset="0"/>
+                              </a:rPr>
+                              <m:t>∗</m:t>
+                            </m:r>
+                          </m:sup>
+                        </m:sSup>
+                        <m:r>
+                          <a:rPr lang="en-US" b="0" i="1" smtClean="0">
+                            <a:latin typeface="Cambria Math" panose="02040503050406030204" pitchFamily="18" charset="0"/>
+                          </a:rPr>
+                          <m:t>, </m:t>
+                        </m:r>
+                        <m:sSup>
+                          <m:sSupPr>
+                            <m:ctrlPr>
+                              <a:rPr lang="en-US" b="0" i="1" smtClean="0">
+                                <a:latin typeface="Cambria Math" panose="02040503050406030204" pitchFamily="18" charset="0"/>
+                              </a:rPr>
+                            </m:ctrlPr>
+                          </m:sSupPr>
+                          <m:e>
+                            <m:r>
+                              <a:rPr lang="en-US" b="0" i="1" smtClean="0">
+                                <a:latin typeface="Cambria Math" panose="02040503050406030204" pitchFamily="18" charset="0"/>
+                              </a:rPr>
+                              <m:t>𝑣</m:t>
+                            </m:r>
+                          </m:e>
+                          <m:sup>
+                            <m:r>
+                              <a:rPr lang="en-US" b="0" i="1" smtClean="0">
+                                <a:latin typeface="Cambria Math" panose="02040503050406030204" pitchFamily="18" charset="0"/>
+                              </a:rPr>
+                              <m:t>∗</m:t>
+                            </m:r>
+                          </m:sup>
+                        </m:sSup>
+                      </m:e>
+                    </m:d>
+                  </m:oMath>
+                </a14:m>
+                <a:r>
+                  <a:rPr lang="ru-RU" dirty="0"/>
+                  <a:t>, для его корректировки предлагается искать минимум следующего функционала:</a:t>
+                </a:r>
+              </a:p>
+              <a:p>
+                <a14:m>
+                  <m:oMathPara xmlns:m="http://schemas.openxmlformats.org/officeDocument/2006/math">
+                    <m:oMathParaPr>
+                      <m:jc m:val="centerGroup"/>
+                    </m:oMathParaPr>
+                    <m:oMath xmlns:m="http://schemas.openxmlformats.org/officeDocument/2006/math">
+                      <m:r>
+                        <a:rPr lang="en-US" b="0" i="1" smtClean="0">
+                          <a:latin typeface="Cambria Math" panose="02040503050406030204" pitchFamily="18" charset="0"/>
+                        </a:rPr>
+                        <m:t>𝑆</m:t>
+                      </m:r>
+                      <m:d>
+                        <m:dPr>
+                          <m:ctrlPr>
+                            <a:rPr lang="en-US" b="0" i="1" smtClean="0">
+                              <a:latin typeface="Cambria Math" panose="02040503050406030204" pitchFamily="18" charset="0"/>
+                            </a:rPr>
+                          </m:ctrlPr>
+                        </m:dPr>
+                        <m:e>
+                          <m:r>
+                            <a:rPr lang="en-US" b="0" i="1" smtClean="0">
+                              <a:latin typeface="Cambria Math" panose="02040503050406030204" pitchFamily="18" charset="0"/>
+                            </a:rPr>
+                            <m:t>𝑢</m:t>
+                          </m:r>
+                          <m:r>
+                            <a:rPr lang="en-US" b="0" i="1" smtClean="0">
+                              <a:latin typeface="Cambria Math" panose="02040503050406030204" pitchFamily="18" charset="0"/>
+                            </a:rPr>
+                            <m:t>, </m:t>
+                          </m:r>
+                          <m:r>
+                            <a:rPr lang="en-US" b="0" i="1" smtClean="0">
+                              <a:latin typeface="Cambria Math" panose="02040503050406030204" pitchFamily="18" charset="0"/>
+                            </a:rPr>
+                            <m:t>𝑣</m:t>
+                          </m:r>
+                        </m:e>
+                      </m:d>
+                      <m:r>
+                        <a:rPr lang="en-US" b="0" i="1" smtClean="0">
+                          <a:latin typeface="Cambria Math" panose="02040503050406030204" pitchFamily="18" charset="0"/>
+                        </a:rPr>
+                        <m:t>=</m:t>
+                      </m:r>
+                      <m:sSubSup>
+                        <m:sSubSupPr>
+                          <m:ctrlPr>
+                            <a:rPr lang="en-US" b="0" i="1" smtClean="0">
+                              <a:latin typeface="Cambria Math" panose="02040503050406030204" pitchFamily="18" charset="0"/>
+                            </a:rPr>
+                          </m:ctrlPr>
+                        </m:sSubSupPr>
+                        <m:e>
+                          <m:d>
+                            <m:dPr>
+                              <m:begChr m:val="|"/>
+                              <m:endChr m:val="|"/>
+                              <m:ctrlPr>
+                                <a:rPr lang="en-US" b="0" i="1" smtClean="0">
+                                  <a:latin typeface="Cambria Math" panose="02040503050406030204" pitchFamily="18" charset="0"/>
+                                </a:rPr>
+                              </m:ctrlPr>
+                            </m:dPr>
+                            <m:e>
+                              <m:d>
+                                <m:dPr>
+                                  <m:begChr m:val="|"/>
+                                  <m:endChr m:val="|"/>
+                                  <m:ctrlPr>
+                                    <a:rPr lang="en-US" b="0" i="1" smtClean="0">
+                                      <a:latin typeface="Cambria Math" panose="02040503050406030204" pitchFamily="18" charset="0"/>
+                                    </a:rPr>
+                                  </m:ctrlPr>
+                                </m:dPr>
+                                <m:e>
+                                  <m:r>
+                                    <a:rPr lang="en-US" b="0" i="1" smtClean="0">
+                                      <a:latin typeface="Cambria Math" panose="02040503050406030204" pitchFamily="18" charset="0"/>
+                                    </a:rPr>
+                                    <m:t>𝑢</m:t>
+                                  </m:r>
+                                  <m:r>
+                                    <a:rPr lang="en-US" b="0" i="1" smtClean="0">
+                                      <a:latin typeface="Cambria Math" panose="02040503050406030204" pitchFamily="18" charset="0"/>
+                                    </a:rPr>
+                                    <m:t>−</m:t>
+                                  </m:r>
+                                  <m:sSup>
+                                    <m:sSupPr>
+                                      <m:ctrlPr>
+                                        <a:rPr lang="en-US" b="0" i="1" smtClean="0">
+                                          <a:latin typeface="Cambria Math" panose="02040503050406030204" pitchFamily="18" charset="0"/>
+                                        </a:rPr>
+                                      </m:ctrlPr>
+                                    </m:sSupPr>
+                                    <m:e>
+                                      <m:r>
+                                        <a:rPr lang="en-US" b="0" i="1" smtClean="0">
+                                          <a:latin typeface="Cambria Math" panose="02040503050406030204" pitchFamily="18" charset="0"/>
+                                        </a:rPr>
+                                        <m:t>𝑢</m:t>
+                                      </m:r>
+                                    </m:e>
+                                    <m:sup>
+                                      <m:r>
+                                        <a:rPr lang="en-US" b="0" i="1" smtClean="0">
+                                          <a:latin typeface="Cambria Math" panose="02040503050406030204" pitchFamily="18" charset="0"/>
+                                        </a:rPr>
+                                        <m:t>∗</m:t>
+                                      </m:r>
+                                    </m:sup>
+                                  </m:sSup>
+                                </m:e>
+                              </m:d>
+                            </m:e>
+                          </m:d>
+                        </m:e>
+                        <m:sub>
+                          <m:r>
+                            <a:rPr lang="en-US" b="0" i="1" smtClean="0">
+                              <a:latin typeface="Cambria Math" panose="02040503050406030204" pitchFamily="18" charset="0"/>
+                            </a:rPr>
+                            <m:t>2</m:t>
+                          </m:r>
+                        </m:sub>
+                        <m:sup>
+                          <m:r>
+                            <a:rPr lang="en-US" b="0" i="1" smtClean="0">
+                              <a:latin typeface="Cambria Math" panose="02040503050406030204" pitchFamily="18" charset="0"/>
+                            </a:rPr>
+                            <m:t>2</m:t>
+                          </m:r>
+                        </m:sup>
+                      </m:sSubSup>
+                      <m:r>
+                        <a:rPr lang="en-US" b="0" i="1" smtClean="0">
+                          <a:latin typeface="Cambria Math" panose="02040503050406030204" pitchFamily="18" charset="0"/>
+                        </a:rPr>
+                        <m:t>+</m:t>
+                      </m:r>
+                      <m:sSubSup>
+                        <m:sSubSupPr>
+                          <m:ctrlPr>
+                            <a:rPr lang="en-US" b="0" i="1" smtClean="0">
+                              <a:latin typeface="Cambria Math" panose="02040503050406030204" pitchFamily="18" charset="0"/>
+                            </a:rPr>
+                          </m:ctrlPr>
+                        </m:sSubSupPr>
+                        <m:e>
+                          <m:d>
+                            <m:dPr>
+                              <m:begChr m:val="|"/>
+                              <m:endChr m:val="|"/>
+                              <m:ctrlPr>
+                                <a:rPr lang="en-US" b="0" i="1" smtClean="0">
+                                  <a:latin typeface="Cambria Math" panose="02040503050406030204" pitchFamily="18" charset="0"/>
+                                </a:rPr>
+                              </m:ctrlPr>
+                            </m:dPr>
+                            <m:e>
+                              <m:d>
+                                <m:dPr>
+                                  <m:begChr m:val="|"/>
+                                  <m:endChr m:val="|"/>
+                                  <m:ctrlPr>
+                                    <a:rPr lang="en-US" b="0" i="1" smtClean="0">
+                                      <a:latin typeface="Cambria Math" panose="02040503050406030204" pitchFamily="18" charset="0"/>
+                                    </a:rPr>
+                                  </m:ctrlPr>
+                                </m:dPr>
+                                <m:e>
+                                  <m:r>
+                                    <a:rPr lang="en-US" b="0" i="1" smtClean="0">
+                                      <a:latin typeface="Cambria Math" panose="02040503050406030204" pitchFamily="18" charset="0"/>
+                                    </a:rPr>
+                                    <m:t>𝑣</m:t>
+                                  </m:r>
+                                  <m:r>
+                                    <a:rPr lang="en-US" b="0" i="1" smtClean="0">
+                                      <a:latin typeface="Cambria Math" panose="02040503050406030204" pitchFamily="18" charset="0"/>
+                                    </a:rPr>
+                                    <m:t> −</m:t>
+                                  </m:r>
+                                  <m:sSup>
+                                    <m:sSupPr>
+                                      <m:ctrlPr>
+                                        <a:rPr lang="en-US" b="0" i="1" smtClean="0">
+                                          <a:latin typeface="Cambria Math" panose="02040503050406030204" pitchFamily="18" charset="0"/>
+                                        </a:rPr>
+                                      </m:ctrlPr>
+                                    </m:sSupPr>
+                                    <m:e>
+                                      <m:r>
+                                        <a:rPr lang="en-US" b="0" i="1" smtClean="0">
+                                          <a:latin typeface="Cambria Math" panose="02040503050406030204" pitchFamily="18" charset="0"/>
+                                        </a:rPr>
+                                        <m:t>𝑣</m:t>
+                                      </m:r>
+                                    </m:e>
+                                    <m:sup>
+                                      <m:r>
+                                        <a:rPr lang="en-US" b="0" i="1" smtClean="0">
+                                          <a:latin typeface="Cambria Math" panose="02040503050406030204" pitchFamily="18" charset="0"/>
+                                        </a:rPr>
+                                        <m:t>∗</m:t>
+                                      </m:r>
+                                    </m:sup>
+                                  </m:sSup>
+                                </m:e>
+                              </m:d>
+                            </m:e>
+                          </m:d>
+                        </m:e>
+                        <m:sub>
+                          <m:r>
+                            <a:rPr lang="en-US" b="0" i="1" smtClean="0">
+                              <a:latin typeface="Cambria Math" panose="02040503050406030204" pitchFamily="18" charset="0"/>
+                            </a:rPr>
+                            <m:t>2</m:t>
+                          </m:r>
+                        </m:sub>
+                        <m:sup>
+                          <m:r>
+                            <a:rPr lang="en-US" b="0" i="1" smtClean="0">
+                              <a:latin typeface="Cambria Math" panose="02040503050406030204" pitchFamily="18" charset="0"/>
+                            </a:rPr>
+                            <m:t>2</m:t>
+                          </m:r>
+                        </m:sup>
+                      </m:sSubSup>
+                    </m:oMath>
+                  </m:oMathPara>
+                </a14:m>
+                <a:endParaRPr lang="en-US" dirty="0"/>
+              </a:p>
+              <a:p>
+                <a:r>
+                  <a:rPr lang="ru-RU" dirty="0"/>
+                  <a:t>При</a:t>
+                </a:r>
+                <a:r>
+                  <a:rPr lang="en-US" b="0" dirty="0"/>
+                  <a:t> </a:t>
+                </a:r>
+                <a14:m>
+                  <m:oMath xmlns:m="http://schemas.openxmlformats.org/officeDocument/2006/math">
+                    <m:r>
+                      <a:rPr lang="en-US" b="0" i="1" smtClean="0">
+                        <a:latin typeface="Cambria Math" panose="02040503050406030204" pitchFamily="18" charset="0"/>
+                      </a:rPr>
+                      <m:t>𝑛</m:t>
+                    </m:r>
+                  </m:oMath>
+                </a14:m>
+                <a:r>
+                  <a:rPr lang="ru-RU" dirty="0"/>
+                  <a:t> условиях полученных из уравнения неразрывности. </a:t>
+                </a:r>
+              </a:p>
+            </p:txBody>
+          </p:sp>
+        </mc:Choice>
+        <mc:Fallback>
+          <p:sp>
+            <p:nvSpPr>
+              <p:cNvPr id="6" name="TextBox 5">
+                <a:extLst>
+                  <a:ext uri="{FF2B5EF4-FFF2-40B4-BE49-F238E27FC236}">
+                    <a16:creationId xmlns:a16="http://schemas.microsoft.com/office/drawing/2014/main" id="{37A5E661-2DD6-489C-81CA-B9C5D0158264}"/>
+                  </a:ext>
+                </a:extLst>
+              </p:cNvPr>
+              <p:cNvSpPr txBox="1">
+                <a:spLocks noRot="1" noChangeAspect="1" noMove="1" noResize="1" noEditPoints="1" noAdjustHandles="1" noChangeArrowheads="1" noChangeShapeType="1" noTextEdit="1"/>
+              </p:cNvSpPr>
+              <p:nvPr/>
+            </p:nvSpPr>
+            <p:spPr>
+              <a:xfrm>
+                <a:off x="904924" y="1743519"/>
+                <a:ext cx="5614322" cy="4118692"/>
+              </a:xfrm>
+              <a:prstGeom prst="rect">
+                <a:avLst/>
+              </a:prstGeom>
+              <a:blipFill>
+                <a:blip r:embed="rId2"/>
+                <a:stretch>
+                  <a:fillRect l="-869" t="-740" r="-1194" b="-1331"/>
+                </a:stretch>
+              </a:blipFill>
+            </p:spPr>
+            <p:txBody>
+              <a:bodyPr/>
+              <a:lstStyle/>
+              <a:p>
+                <a:r>
+                  <a:rPr lang="ru-RU">
+                    <a:noFill/>
+                  </a:rPr>
+                  <a:t> </a:t>
+                </a:r>
+              </a:p>
+            </p:txBody>
+          </p:sp>
+        </mc:Fallback>
+      </mc:AlternateContent>
+      <p:pic>
+        <p:nvPicPr>
+          <p:cNvPr id="5" name="Рисунок 4">
+            <a:extLst>
+              <a:ext uri="{FF2B5EF4-FFF2-40B4-BE49-F238E27FC236}">
+                <a16:creationId xmlns:a16="http://schemas.microsoft.com/office/drawing/2014/main" id="{480CAD98-CD58-408D-95CE-828D3E0BD9B8}"/>
+              </a:ext>
+            </a:extLst>
+          </p:cNvPr>
+          <p:cNvPicPr>
+            <a:picLocks noChangeAspect="1"/>
+          </p:cNvPicPr>
+          <p:nvPr/>
+        </p:nvPicPr>
+        <p:blipFill>
+          <a:blip r:embed="rId3"/>
+          <a:stretch>
+            <a:fillRect/>
+          </a:stretch>
+        </p:blipFill>
+        <p:spPr>
+          <a:xfrm>
+            <a:off x="8779187" y="303806"/>
+            <a:ext cx="3183861" cy="3148168"/>
+          </a:xfrm>
+          <a:prstGeom prst="rect">
+            <a:avLst/>
+          </a:prstGeom>
+        </p:spPr>
+      </p:pic>
+      <p:pic>
+        <p:nvPicPr>
+          <p:cNvPr id="8" name="Рисунок 7">
+            <a:extLst>
+              <a:ext uri="{FF2B5EF4-FFF2-40B4-BE49-F238E27FC236}">
+                <a16:creationId xmlns:a16="http://schemas.microsoft.com/office/drawing/2014/main" id="{2CB6EA9F-F76E-489C-A7E0-FD0842D38EF6}"/>
+              </a:ext>
+            </a:extLst>
+          </p:cNvPr>
+          <p:cNvPicPr>
+            <a:picLocks noChangeAspect="1"/>
+          </p:cNvPicPr>
+          <p:nvPr/>
+        </p:nvPicPr>
+        <p:blipFill>
+          <a:blip r:embed="rId4"/>
+          <a:stretch>
+            <a:fillRect/>
+          </a:stretch>
+        </p:blipFill>
+        <p:spPr>
+          <a:xfrm>
+            <a:off x="8841029" y="3557909"/>
+            <a:ext cx="3122019" cy="3086380"/>
+          </a:xfrm>
+          <a:prstGeom prst="rect">
+            <a:avLst/>
+          </a:prstGeom>
+        </p:spPr>
+      </p:pic>
+      <p:sp>
+        <p:nvSpPr>
+          <p:cNvPr id="9" name="TextBox 8">
+            <a:extLst>
+              <a:ext uri="{FF2B5EF4-FFF2-40B4-BE49-F238E27FC236}">
+                <a16:creationId xmlns:a16="http://schemas.microsoft.com/office/drawing/2014/main" id="{4770C96B-F7C7-4AB2-B430-5DEB1CD9C897}"/>
+              </a:ext>
+            </a:extLst>
+          </p:cNvPr>
+          <p:cNvSpPr txBox="1"/>
+          <p:nvPr/>
+        </p:nvSpPr>
+        <p:spPr>
+          <a:xfrm>
+            <a:off x="6965391" y="3686285"/>
+            <a:ext cx="1966196" cy="646331"/>
+          </a:xfrm>
+          <a:prstGeom prst="rect">
+            <a:avLst/>
+          </a:prstGeom>
+          <a:noFill/>
+        </p:spPr>
+        <p:txBody>
+          <a:bodyPr wrap="square" rtlCol="0">
+            <a:spAutoFit/>
+          </a:bodyPr>
+          <a:lstStyle/>
+          <a:p>
+            <a:r>
+              <a:rPr lang="ru-RU" dirty="0"/>
+              <a:t>С коррекцией.</a:t>
+            </a:r>
+          </a:p>
+          <a:p>
+            <a:r>
+              <a:rPr lang="ru-RU" dirty="0"/>
+              <a:t>Ошибка 0.0035</a:t>
+            </a:r>
+          </a:p>
+        </p:txBody>
+      </p:sp>
+      <p:sp>
+        <p:nvSpPr>
+          <p:cNvPr id="10" name="TextBox 9">
+            <a:extLst>
+              <a:ext uri="{FF2B5EF4-FFF2-40B4-BE49-F238E27FC236}">
+                <a16:creationId xmlns:a16="http://schemas.microsoft.com/office/drawing/2014/main" id="{E9182B22-D54C-4EFD-8991-B26EDD987160}"/>
+              </a:ext>
+            </a:extLst>
+          </p:cNvPr>
+          <p:cNvSpPr txBox="1"/>
+          <p:nvPr/>
+        </p:nvSpPr>
+        <p:spPr>
+          <a:xfrm>
+            <a:off x="6965391" y="725677"/>
+            <a:ext cx="1966196" cy="646331"/>
+          </a:xfrm>
+          <a:prstGeom prst="rect">
+            <a:avLst/>
+          </a:prstGeom>
+          <a:noFill/>
+        </p:spPr>
+        <p:txBody>
+          <a:bodyPr wrap="square" rtlCol="0">
+            <a:spAutoFit/>
+          </a:bodyPr>
+          <a:lstStyle/>
+          <a:p>
+            <a:r>
+              <a:rPr lang="ru-RU" dirty="0"/>
+              <a:t>Без коррекции.</a:t>
+            </a:r>
+          </a:p>
+          <a:p>
+            <a:r>
+              <a:rPr lang="ru-RU" dirty="0"/>
+              <a:t>Ошибка 0.0048</a:t>
+            </a:r>
+          </a:p>
+        </p:txBody>
+      </p:sp>
+    </p:spTree>
+    <p:extLst>
+      <p:ext uri="{BB962C8B-B14F-4D97-AF65-F5344CB8AC3E}">
+        <p14:creationId xmlns:p14="http://schemas.microsoft.com/office/powerpoint/2010/main" val="1533136576"/>
       </p:ext>
     </p:extLst>
   </p:cSld>

</xml_diff>